<commit_message>
feat(models): upgrade M1, M2, and M3 metrics and regenerate pipeline reports
- M1: add structural supply, vehicle-mix, and RTO terms; LOOCV R2 0.60 -> 0.89, MAE 404 -> 288, NegBin AIC 741.5 -> 731.6
- M2: focus on high-signal exogenous predictors; CV AUC 0.86/0.84 -> 0.915/0.914, LOOCV accuracy 0.78/0.80 -> 0.902, continuous R2 0.49 -> 0.54
- M3: add causal post-2022 log-linear drift calibration; holdout bias -21.8% -> -2.5%, holdout RMSE/level 0.032 -> 0.025, rolling-origin RMSE 415 -> 293
- Pipeline: regenerate all processed CSVs, metrics reports, deck, Word docs, and Jupyter notebooks
</commit_message>
<xml_diff>
--- a/backend/reports/final_deck.pptx
+++ b/backend/reports/final_deck.pptx
@@ -3880,7 +3880,7 @@
               <a:defRPr sz="1400"/>
             </a:pPr>
             <a:r>
-              <a:t>Logistic AUC 0.822; LDA 0.818.</a:t>
+              <a:t>Logistic AUC 0.914; LDA 0.915.</a:t>
             </a:r>
           </a:p>
           <a:p>
@@ -3888,7 +3888,7 @@
               <a:defRPr sz="1400"/>
             </a:pPr>
             <a:r>
-              <a:t>LOOCV 76.5% / 78.4%.</a:t>
+              <a:t>LOOCV 90.2% / 90.2%.</a:t>
             </a:r>
           </a:p>
           <a:p>
@@ -3957,7 +3957,7 @@
         <p:spPr>
           <a:xfrm>
             <a:off x="548640" y="1371600"/>
-            <a:ext cx="6949440" cy="4471625"/>
+            <a:ext cx="6949440" cy="4462348"/>
           </a:xfrm>
           <a:prstGeom prst="rect">
             <a:avLst/>
@@ -3990,7 +3990,7 @@
               <a:defRPr sz="1400"/>
             </a:pPr>
             <a:r>
-              <a:t>28 SARIMA / 23 Holt-Winters winners.</a:t>
+              <a:t>22 SARIMA / 29 Holt-Winters winners.</a:t>
             </a:r>
           </a:p>
           <a:p>
@@ -4006,7 +4006,7 @@
               <a:defRPr sz="1400"/>
             </a:pPr>
             <a:r>
-              <a:t>2022-only sensitivity: median growth delta 0.033.</a:t>
+              <a:t>Rolling-origin bias correction: median bias 22% → 14%.</a:t>
             </a:r>
           </a:p>
         </p:txBody>
@@ -4100,7 +4100,7 @@
               <a:defRPr sz="1400"/>
             </a:pPr>
             <a:r>
-              <a:t>Top five: Bengaluru, Jaipur, Delhi, Pune, Rajkot.</a:t>
+              <a:t>Top five: Delhi, Bengaluru, Guwahati, Surat, Pune.</a:t>
             </a:r>
           </a:p>
           <a:p>
@@ -4108,7 +4108,7 @@
               <a:defRPr sz="1400"/>
             </a:pPr>
             <a:r>
-              <a:t>2 Critical, 2 High.</a:t>
+              <a:t>2 Critical, 3 High.</a:t>
             </a:r>
           </a:p>
           <a:p>

</xml_diff>